<commit_message>
chore: align Russian speech contracts and MVP presentation
</commit_message>
<xml_diff>
--- a/docs/delivery/presentation.pptx
+++ b/docs/delivery/presentation.pptx
@@ -2,20 +2,20 @@
 <file path=ppt/presentation.xml><?xml version="1.0" encoding="utf-8"?>
 <p:presentation xmlns:p="http://schemas.openxmlformats.org/presentationml/2006/main">
   <p:sldMasterIdLst>
-    <p:sldMasterId xmlns:r="http://schemas.openxmlformats.org/officeDocument/2006/relationships" id="2147483648" r:id="Rdf7ce14de1394741"/>
+    <p:sldMasterId xmlns:r="http://schemas.openxmlformats.org/officeDocument/2006/relationships" id="2147483648" r:id="R81c38b21ab01445a"/>
   </p:sldMasterIdLst>
   <p:notesMasterIdLst>
-    <p:notesMasterId xmlns:r="http://schemas.openxmlformats.org/officeDocument/2006/relationships" r:id="R0e9ccbf2d1eb4ed7"/>
+    <p:notesMasterId xmlns:r="http://schemas.openxmlformats.org/officeDocument/2006/relationships" r:id="R8ee9a4b900884a02"/>
   </p:notesMasterIdLst>
   <p:sldIdLst>
-    <p:sldId xmlns:r="http://schemas.openxmlformats.org/officeDocument/2006/relationships" id="256" r:id="R2abee39f588f43f2"/>
-    <p:sldId xmlns:r="http://schemas.openxmlformats.org/officeDocument/2006/relationships" id="257" r:id="R5d02c6438e1f4d34"/>
-    <p:sldId xmlns:r="http://schemas.openxmlformats.org/officeDocument/2006/relationships" id="258" r:id="R822196cc46ba4b34"/>
-    <p:sldId xmlns:r="http://schemas.openxmlformats.org/officeDocument/2006/relationships" id="259" r:id="R0787c01cfa234519"/>
-    <p:sldId xmlns:r="http://schemas.openxmlformats.org/officeDocument/2006/relationships" id="260" r:id="Rfdebd8aca21f4447"/>
-    <p:sldId xmlns:r="http://schemas.openxmlformats.org/officeDocument/2006/relationships" id="261" r:id="R0e6583c517424479"/>
-    <p:sldId xmlns:r="http://schemas.openxmlformats.org/officeDocument/2006/relationships" id="262" r:id="R83e250df729346df"/>
-    <p:sldId xmlns:r="http://schemas.openxmlformats.org/officeDocument/2006/relationships" id="263" r:id="R27d46366dd714cb6"/>
+    <p:sldId xmlns:r="http://schemas.openxmlformats.org/officeDocument/2006/relationships" id="256" r:id="Reb4a308493b74886"/>
+    <p:sldId xmlns:r="http://schemas.openxmlformats.org/officeDocument/2006/relationships" id="257" r:id="Re759d5accd47450b"/>
+    <p:sldId xmlns:r="http://schemas.openxmlformats.org/officeDocument/2006/relationships" id="258" r:id="R1cfc8bbc469449ed"/>
+    <p:sldId xmlns:r="http://schemas.openxmlformats.org/officeDocument/2006/relationships" id="259" r:id="R09f5fca884f143e5"/>
+    <p:sldId xmlns:r="http://schemas.openxmlformats.org/officeDocument/2006/relationships" id="260" r:id="Rfb28452e1d594b64"/>
+    <p:sldId xmlns:r="http://schemas.openxmlformats.org/officeDocument/2006/relationships" id="261" r:id="Rc685097e94bb4428"/>
+    <p:sldId xmlns:r="http://schemas.openxmlformats.org/officeDocument/2006/relationships" id="262" r:id="Rc6ae8e1fafa04cd3"/>
+    <p:sldId xmlns:r="http://schemas.openxmlformats.org/officeDocument/2006/relationships" id="263" r:id="R355d99cbab714fe8"/>
   </p:sldIdLst>
   <p:sldSz cx="12192000" cy="6858000"/>
   <p:notesSz cx="6858000" cy="9144000"/>
@@ -589,7 +589,7 @@
           <a:lstStyle xmlns:a="http://schemas.openxmlformats.org/drawingml/2006/main"/>
           <a:p xmlns:a="http://schemas.openxmlformats.org/drawingml/2006/main">
             <a:r>
-              <a:t>Покажите живой сценарий из docs/demo.md. iPhone устанавливает PWA через Safari; Android через Chrome. Персональные данные в демонстрации не используются.</a:t>
+              <a:t>Согласованный MVP: docs/superpowers/plans/2026-10-08-mvp-finalization.md. Голос не отправляет отчёт автоматически. Физические телефоны и мобильные замеры отложены.</a:t>
             </a:r>
           </a:p>
         </p:txBody>
@@ -659,7 +659,7 @@
           <a:lstStyle xmlns:a="http://schemas.openxmlformats.org/drawingml/2006/main"/>
           <a:p xmlns:a="http://schemas.openxmlformats.org/drawingml/2006/main">
             <a:r>
-              <a:t>Источники: plans.md C5, docs/T07-quality-verification.md. ИИ не удостоверяет исправность скрытых узлов или безопасность запуска по одному фото. Маленький фотонабор не доказывает производственную точность.</a:t>
+              <a:t>Три подготовленных результата помечены как демонстрационные, is_mock=true; модель при подготовке не вызывается. Они показывают сценарии продукта, не доказывают точность ИИ. Живой ИИ анализирует заявку, отчёт и фотографии до/после в общем бюджете $10. Источник: docs/MVP-finalization-verification.md.</a:t>
             </a:r>
           </a:p>
         </p:txBody>
@@ -939,7 +939,7 @@
           <a:lstStyle xmlns:a="http://schemas.openxmlformats.org/drawingml/2006/main"/>
           <a:p xmlns:a="http://schemas.openxmlformats.org/drawingml/2006/main">
             <a:r>
-              <a:t>Фактический результат и commit SHA см. docs/verification.md. Мобильные числа являются критериями, пока реальные замеры не записаны. HTTPS-туннель временный, компьютер работает без сна. Дополнительный лимит живого ИИ $2.</a:t>
+              <a:t>Фактические результаты и commit SHA: docs/MVP-finalization-verification.md. Демонстрационный стенд использует синтетические данные. Quick Tunnel требует включённого компьютера. Цели ≤60с/≤6 действий, события≤5с, фото≤10с ещё не измерены на физических телефонах.</a:t>
             </a:r>
           </a:p>
         </p:txBody>
@@ -1007,7 +1007,7 @@
   </p:cSld>
   <p:clrMap bg1="lt1" tx1="dk1" bg2="lt2" tx2="dk2" accent1="accent1" accent2="accent2" accent3="accent3" accent4="accent4" accent5="accent5" accent6="accent6" hlink="hlink" folHlink="folHlink"/>
   <p:sldLayoutIdLst>
-    <p:sldLayoutId xmlns:r="http://schemas.openxmlformats.org/officeDocument/2006/relationships" id="2147483649" r:id="R5a4e436bfcae41e3"/>
+    <p:sldLayoutId xmlns:r="http://schemas.openxmlformats.org/officeDocument/2006/relationships" id="2147483649" r:id="Rb16cf9ac845f4911"/>
   </p:sldLayoutIdLst>
   <p:txStyles>
     <p:titleStyle>
@@ -1587,6 +1587,7 @@
           <a:lstStyle xmlns:a="http://schemas.openxmlformats.org/drawingml/2006/main"/>
           <a:p xmlns:a="http://schemas.openxmlformats.org/drawingml/2006/main">
             <a:pPr>
+              <a:buNone/>
               <a:defRPr sz="5700" b="1">
                 <a:solidFill>
                   <a:srgbClr val="183038"/>
@@ -1644,6 +1645,7 @@
           <a:lstStyle xmlns:a="http://schemas.openxmlformats.org/drawingml/2006/main"/>
           <a:p xmlns:a="http://schemas.openxmlformats.org/drawingml/2006/main">
             <a:pPr>
+              <a:buNone/>
               <a:defRPr sz="2700">
                 <a:solidFill>
                   <a:srgbClr val="264A54"/>
@@ -1667,6 +1669,7 @@
           </a:p>
           <a:p xmlns:a="http://schemas.openxmlformats.org/drawingml/2006/main">
             <a:pPr>
+              <a:buNone/>
               <a:defRPr sz="2700">
                 <a:solidFill>
                   <a:srgbClr val="264A54"/>
@@ -1722,6 +1725,7 @@
           <a:lstStyle xmlns:a="http://schemas.openxmlformats.org/drawingml/2006/main"/>
           <a:p xmlns:a="http://schemas.openxmlformats.org/drawingml/2006/main">
             <a:pPr>
+              <a:buNone/>
               <a:defRPr sz="1500">
                 <a:solidFill>
                   <a:srgbClr val="667E86"/>
@@ -1808,6 +1812,7 @@
           <a:lstStyle xmlns:a="http://schemas.openxmlformats.org/drawingml/2006/main"/>
           <a:p xmlns:a="http://schemas.openxmlformats.org/drawingml/2006/main">
             <a:pPr>
+              <a:buNone/>
               <a:defRPr sz="3600" b="1">
                 <a:solidFill>
                   <a:srgbClr val="183038"/>
@@ -1865,6 +1870,7 @@
           <a:lstStyle xmlns:a="http://schemas.openxmlformats.org/drawingml/2006/main"/>
           <a:p xmlns:a="http://schemas.openxmlformats.org/drawingml/2006/main">
             <a:pPr>
+              <a:buNone/>
               <a:defRPr sz="2400">
                 <a:solidFill>
                   <a:srgbClr val="264A54"/>
@@ -1888,6 +1894,7 @@
           </a:p>
           <a:p xmlns:a="http://schemas.openxmlformats.org/drawingml/2006/main">
             <a:pPr>
+              <a:buNone/>
               <a:defRPr sz="2400">
                 <a:solidFill>
                   <a:srgbClr val="264A54"/>
@@ -1911,6 +1918,7 @@
           </a:p>
           <a:p xmlns:a="http://schemas.openxmlformats.org/drawingml/2006/main">
             <a:pPr>
+              <a:buNone/>
               <a:defRPr sz="2400">
                 <a:solidFill>
                   <a:srgbClr val="264A54"/>
@@ -1966,6 +1974,7 @@
           <a:lstStyle xmlns:a="http://schemas.openxmlformats.org/drawingml/2006/main"/>
           <a:p xmlns:a="http://schemas.openxmlformats.org/drawingml/2006/main">
             <a:pPr>
+              <a:buNone/>
               <a:defRPr sz="1500">
                 <a:solidFill>
                   <a:srgbClr val="667E86"/>
@@ -2052,6 +2061,7 @@
           <a:lstStyle xmlns:a="http://schemas.openxmlformats.org/drawingml/2006/main"/>
           <a:p xmlns:a="http://schemas.openxmlformats.org/drawingml/2006/main">
             <a:pPr>
+              <a:buNone/>
               <a:defRPr sz="3600" b="1">
                 <a:solidFill>
                   <a:srgbClr val="183038"/>
@@ -2070,7 +2080,7 @@
                 <a:ea typeface="Arial"/>
                 <a:cs typeface="Arial"/>
               </a:rPr>
-              <a:t>Работа с телефона</a:t>
+              <a:t>Работа в PWA</a:t>
             </a:r>
           </a:p>
         </p:txBody>
@@ -2109,6 +2119,7 @@
           <a:lstStyle xmlns:a="http://schemas.openxmlformats.org/drawingml/2006/main"/>
           <a:p xmlns:a="http://schemas.openxmlformats.org/drawingml/2006/main">
             <a:pPr>
+              <a:buNone/>
               <a:defRPr sz="2400">
                 <a:solidFill>
                   <a:srgbClr val="264A54"/>
@@ -2127,11 +2138,12 @@
                 <a:ea typeface="Arial"/>
                 <a:cs typeface="Arial"/>
               </a:rPr>
-              <a:t>Панель смены и выдача наряда</a:t>
-            </a:r>
-          </a:p>
-          <a:p xmlns:a="http://schemas.openxmlformats.org/drawingml/2006/main">
-            <a:pPr>
+              <a:t>Русский и казахский интерфейс</a:t>
+            </a:r>
+          </a:p>
+          <a:p xmlns:a="http://schemas.openxmlformats.org/drawingml/2006/main">
+            <a:pPr>
+              <a:buNone/>
               <a:defRPr sz="2400">
                 <a:solidFill>
                   <a:srgbClr val="264A54"/>
@@ -2150,11 +2162,12 @@
                 <a:ea typeface="Arial"/>
                 <a:cs typeface="Arial"/>
               </a:rPr>
-              <a:t>Telegram со ссылкой в PWA</a:t>
-            </a:r>
-          </a:p>
-          <a:p xmlns:a="http://schemas.openxmlformats.org/drawingml/2006/main">
-            <a:pPr>
+              <a:t>Голосовой ввод на русском с проверкой текста</a:t>
+            </a:r>
+          </a:p>
+          <a:p xmlns:a="http://schemas.openxmlformats.org/drawingml/2006/main">
+            <a:pPr>
+              <a:buNone/>
               <a:defRPr sz="2400">
                 <a:solidFill>
                   <a:srgbClr val="264A54"/>
@@ -2173,11 +2186,12 @@
                 <a:ea typeface="Arial"/>
                 <a:cs typeface="Arial"/>
               </a:rPr>
-              <a:t>Принятие, начало, пауза и отчёт</a:t>
-            </a:r>
-          </a:p>
-          <a:p xmlns:a="http://schemas.openxmlformats.org/drawingml/2006/main">
-            <a:pPr>
+              <a:t>Telegram со ссылкой на наряд</a:t>
+            </a:r>
+          </a:p>
+          <a:p xmlns:a="http://schemas.openxmlformats.org/drawingml/2006/main">
+            <a:pPr>
+              <a:buNone/>
               <a:defRPr sz="2400">
                 <a:solidFill>
                   <a:srgbClr val="264A54"/>
@@ -2196,7 +2210,31 @@
                 <a:ea typeface="Arial"/>
                 <a:cs typeface="Arial"/>
               </a:rPr>
-              <a:t>Решение мастера и обновление панели</a:t>
+              <a:t>Обязательные фото до и после по шаблону</a:t>
+            </a:r>
+          </a:p>
+          <a:p xmlns:a="http://schemas.openxmlformats.org/drawingml/2006/main">
+            <a:pPr>
+              <a:buNone/>
+              <a:defRPr sz="2400">
+                <a:solidFill>
+                  <a:srgbClr val="264A54"/>
+                </a:solidFill>
+                <a:latin typeface="Arial"/>
+                <a:ea typeface="Arial"/>
+                <a:cs typeface="Arial"/>
+              </a:defRPr>
+            </a:pPr>
+            <a:r>
+              <a:rPr sz="2400">
+                <a:solidFill>
+                  <a:srgbClr val="264A54"/>
+                </a:solidFill>
+                <a:latin typeface="Arial"/>
+                <a:ea typeface="Arial"/>
+                <a:cs typeface="Arial"/>
+              </a:rPr>
+              <a:t>Приёмка и история решений мастера</a:t>
             </a:r>
           </a:p>
         </p:txBody>
@@ -2233,6 +2271,7 @@
           <a:lstStyle xmlns:a="http://schemas.openxmlformats.org/drawingml/2006/main"/>
           <a:p xmlns:a="http://schemas.openxmlformats.org/drawingml/2006/main">
             <a:pPr>
+              <a:buNone/>
               <a:defRPr sz="1500">
                 <a:solidFill>
                   <a:srgbClr val="667E86"/>
@@ -2319,6 +2358,7 @@
           <a:lstStyle xmlns:a="http://schemas.openxmlformats.org/drawingml/2006/main"/>
           <a:p xmlns:a="http://schemas.openxmlformats.org/drawingml/2006/main">
             <a:pPr>
+              <a:buNone/>
               <a:defRPr sz="3600" b="1">
                 <a:solidFill>
                   <a:srgbClr val="183038"/>
@@ -2337,7 +2377,7 @@
                 <a:ea typeface="Arial"/>
                 <a:cs typeface="Arial"/>
               </a:rPr>
-              <a:t>Проверка и приёмка</a:t>
+              <a:t>Подготовленные примеры и живой ИИ</a:t>
             </a:r>
           </a:p>
         </p:txBody>
@@ -2376,6 +2416,7 @@
           <a:lstStyle xmlns:a="http://schemas.openxmlformats.org/drawingml/2006/main"/>
           <a:p xmlns:a="http://schemas.openxmlformats.org/drawingml/2006/main">
             <a:pPr>
+              <a:buNone/>
               <a:defRPr sz="2400">
                 <a:solidFill>
                   <a:srgbClr val="264A54"/>
@@ -2394,11 +2435,12 @@
                 <a:ea typeface="Arial"/>
                 <a:cs typeface="Arial"/>
               </a:rPr>
-              <a:t>ИИ сопоставляет проблему, работы и фотографии.</a:t>
-            </a:r>
-          </a:p>
-          <a:p xmlns:a="http://schemas.openxmlformats.org/drawingml/2006/main">
-            <a:pPr>
+              <a:t>Демо: работа соответствует заданию</a:t>
+            </a:r>
+          </a:p>
+          <a:p xmlns:a="http://schemas.openxmlformats.org/drawingml/2006/main">
+            <a:pPr>
+              <a:buNone/>
               <a:defRPr sz="2400">
                 <a:solidFill>
                   <a:srgbClr val="264A54"/>
@@ -2417,11 +2459,12 @@
                 <a:ea typeface="Arial"/>
                 <a:cs typeface="Arial"/>
               </a:rPr>
-              <a:t>Замечания связаны с конкретными доказательствами.</a:t>
-            </a:r>
-          </a:p>
-          <a:p xmlns:a="http://schemas.openxmlformats.org/drawingml/2006/main">
-            <a:pPr>
+              <a:t>Демо: требуется доработка</a:t>
+            </a:r>
+          </a:p>
+          <a:p xmlns:a="http://schemas.openxmlformats.org/drawingml/2006/main">
+            <a:pPr>
+              <a:buNone/>
               <a:defRPr sz="2400">
                 <a:solidFill>
                   <a:srgbClr val="264A54"/>
@@ -2440,11 +2483,36 @@
                 <a:ea typeface="Arial"/>
                 <a:cs typeface="Arial"/>
               </a:rPr>
-              <a:t>Недостаток данных направляет результат человеку.</a:t>
-            </a:r>
-          </a:p>
-          <a:p xmlns:a="http://schemas.openxmlformats.org/drawingml/2006/main">
-            <a:pPr>
+              <a:t>Демо: недостаточно доказательств</a:t>
+            </a:r>
+          </a:p>
+          <a:p xmlns:a="http://schemas.openxmlformats.org/drawingml/2006/main">
+            <a:pPr>
+              <a:buNone/>
+              <a:defRPr sz="2400">
+                <a:solidFill>
+                  <a:srgbClr val="264A54"/>
+                </a:solidFill>
+                <a:latin typeface="Arial"/>
+                <a:ea typeface="Arial"/>
+                <a:cs typeface="Arial"/>
+              </a:defRPr>
+            </a:pPr>
+            <a:r>
+              <a:rPr sz="2400">
+                <a:solidFill>
+                  <a:srgbClr val="264A54"/>
+                </a:solidFill>
+                <a:latin typeface="Arial"/>
+                <a:ea typeface="Arial"/>
+                <a:cs typeface="Arial"/>
+              </a:rPr>
+              <a:t>Новые отчёты проверяет настоящая модель.</a:t>
+            </a:r>
+          </a:p>
+          <a:p xmlns:a="http://schemas.openxmlformats.org/drawingml/2006/main">
+            <a:pPr>
+              <a:buNone/>
               <a:defRPr sz="2400">
                 <a:solidFill>
                   <a:srgbClr val="264A54"/>
@@ -2500,6 +2568,7 @@
           <a:lstStyle xmlns:a="http://schemas.openxmlformats.org/drawingml/2006/main"/>
           <a:p xmlns:a="http://schemas.openxmlformats.org/drawingml/2006/main">
             <a:pPr>
+              <a:buNone/>
               <a:defRPr sz="1500">
                 <a:solidFill>
                   <a:srgbClr val="667E86"/>
@@ -2586,6 +2655,7 @@
           <a:lstStyle xmlns:a="http://schemas.openxmlformats.org/drawingml/2006/main"/>
           <a:p xmlns:a="http://schemas.openxmlformats.org/drawingml/2006/main">
             <a:pPr>
+              <a:buNone/>
               <a:defRPr sz="3600" b="1">
                 <a:solidFill>
                   <a:srgbClr val="183038"/>
@@ -2643,6 +2713,7 @@
           <a:lstStyle xmlns:a="http://schemas.openxmlformats.org/drawingml/2006/main"/>
           <a:p xmlns:a="http://schemas.openxmlformats.org/drawingml/2006/main">
             <a:pPr>
+              <a:buNone/>
               <a:defRPr sz="2400">
                 <a:solidFill>
                   <a:srgbClr val="264A54"/>
@@ -2666,6 +2737,7 @@
           </a:p>
           <a:p xmlns:a="http://schemas.openxmlformats.org/drawingml/2006/main">
             <a:pPr>
+              <a:buNone/>
               <a:defRPr sz="2400">
                 <a:solidFill>
                   <a:srgbClr val="264A54"/>
@@ -2689,6 +2761,7 @@
           </a:p>
           <a:p xmlns:a="http://schemas.openxmlformats.org/drawingml/2006/main">
             <a:pPr>
+              <a:buNone/>
               <a:defRPr sz="2400">
                 <a:solidFill>
                   <a:srgbClr val="264A54"/>
@@ -2712,6 +2785,7 @@
           </a:p>
           <a:p xmlns:a="http://schemas.openxmlformats.org/drawingml/2006/main">
             <a:pPr>
+              <a:buNone/>
               <a:defRPr sz="2400">
                 <a:solidFill>
                   <a:srgbClr val="264A54"/>
@@ -2767,6 +2841,7 @@
           <a:lstStyle xmlns:a="http://schemas.openxmlformats.org/drawingml/2006/main"/>
           <a:p xmlns:a="http://schemas.openxmlformats.org/drawingml/2006/main">
             <a:pPr>
+              <a:buNone/>
               <a:defRPr sz="1500">
                 <a:solidFill>
                   <a:srgbClr val="667E86"/>
@@ -2853,6 +2928,7 @@
           <a:lstStyle xmlns:a="http://schemas.openxmlformats.org/drawingml/2006/main"/>
           <a:p xmlns:a="http://schemas.openxmlformats.org/drawingml/2006/main">
             <a:pPr>
+              <a:buNone/>
               <a:defRPr sz="3600" b="1">
                 <a:solidFill>
                   <a:srgbClr val="183038"/>
@@ -2910,6 +2986,7 @@
           <a:lstStyle xmlns:a="http://schemas.openxmlformats.org/drawingml/2006/main"/>
           <a:p xmlns:a="http://schemas.openxmlformats.org/drawingml/2006/main">
             <a:pPr>
+              <a:buNone/>
               <a:defRPr sz="2400">
                 <a:solidFill>
                   <a:srgbClr val="264A54"/>
@@ -2933,6 +3010,7 @@
           </a:p>
           <a:p xmlns:a="http://schemas.openxmlformats.org/drawingml/2006/main">
             <a:pPr>
+              <a:buNone/>
               <a:defRPr sz="2400">
                 <a:solidFill>
                   <a:srgbClr val="264A54"/>
@@ -2956,6 +3034,7 @@
           </a:p>
           <a:p xmlns:a="http://schemas.openxmlformats.org/drawingml/2006/main">
             <a:pPr>
+              <a:buNone/>
               <a:defRPr sz="2400">
                 <a:solidFill>
                   <a:srgbClr val="264A54"/>
@@ -2979,6 +3058,7 @@
           </a:p>
           <a:p xmlns:a="http://schemas.openxmlformats.org/drawingml/2006/main">
             <a:pPr>
+              <a:buNone/>
               <a:defRPr sz="2400">
                 <a:solidFill>
                   <a:srgbClr val="264A54"/>
@@ -3002,6 +3082,7 @@
           </a:p>
           <a:p xmlns:a="http://schemas.openxmlformats.org/drawingml/2006/main">
             <a:pPr>
+              <a:buNone/>
               <a:defRPr sz="2400">
                 <a:solidFill>
                   <a:srgbClr val="264A54"/>
@@ -3057,6 +3138,7 @@
           <a:lstStyle xmlns:a="http://schemas.openxmlformats.org/drawingml/2006/main"/>
           <a:p xmlns:a="http://schemas.openxmlformats.org/drawingml/2006/main">
             <a:pPr>
+              <a:buNone/>
               <a:defRPr sz="1500">
                 <a:solidFill>
                   <a:srgbClr val="667E86"/>
@@ -3143,6 +3225,7 @@
           <a:lstStyle xmlns:a="http://schemas.openxmlformats.org/drawingml/2006/main"/>
           <a:p xmlns:a="http://schemas.openxmlformats.org/drawingml/2006/main">
             <a:pPr>
+              <a:buNone/>
               <a:defRPr sz="3600" b="1">
                 <a:solidFill>
                   <a:srgbClr val="183038"/>
@@ -3200,6 +3283,7 @@
           <a:lstStyle xmlns:a="http://schemas.openxmlformats.org/drawingml/2006/main"/>
           <a:p xmlns:a="http://schemas.openxmlformats.org/drawingml/2006/main">
             <a:pPr>
+              <a:buNone/>
               <a:defRPr sz="2400">
                 <a:solidFill>
                   <a:srgbClr val="264A54"/>
@@ -3223,6 +3307,7 @@
           </a:p>
           <a:p xmlns:a="http://schemas.openxmlformats.org/drawingml/2006/main">
             <a:pPr>
+              <a:buNone/>
               <a:defRPr sz="2400">
                 <a:solidFill>
                   <a:srgbClr val="264A54"/>
@@ -3246,6 +3331,7 @@
           </a:p>
           <a:p xmlns:a="http://schemas.openxmlformats.org/drawingml/2006/main">
             <a:pPr>
+              <a:buNone/>
               <a:defRPr sz="2400">
                 <a:solidFill>
                   <a:srgbClr val="264A54"/>
@@ -3269,6 +3355,7 @@
           </a:p>
           <a:p xmlns:a="http://schemas.openxmlformats.org/drawingml/2006/main">
             <a:pPr>
+              <a:buNone/>
               <a:defRPr sz="2400">
                 <a:solidFill>
                   <a:srgbClr val="264A54"/>
@@ -3324,6 +3411,7 @@
           <a:lstStyle xmlns:a="http://schemas.openxmlformats.org/drawingml/2006/main"/>
           <a:p xmlns:a="http://schemas.openxmlformats.org/drawingml/2006/main">
             <a:pPr>
+              <a:buNone/>
               <a:defRPr sz="1500">
                 <a:solidFill>
                   <a:srgbClr val="667E86"/>
@@ -3410,6 +3498,7 @@
           <a:lstStyle xmlns:a="http://schemas.openxmlformats.org/drawingml/2006/main"/>
           <a:p xmlns:a="http://schemas.openxmlformats.org/drawingml/2006/main">
             <a:pPr>
+              <a:buNone/>
               <a:defRPr sz="3600" b="1">
                 <a:solidFill>
                   <a:srgbClr val="183038"/>
@@ -3428,7 +3517,7 @@
                 <a:ea typeface="Arial"/>
                 <a:cs typeface="Arial"/>
               </a:rPr>
-              <a:t>Проверка перед применением</a:t>
+              <a:t>Границы демонстрационного релиза</a:t>
             </a:r>
           </a:p>
         </p:txBody>
@@ -3467,6 +3556,7 @@
           <a:lstStyle xmlns:a="http://schemas.openxmlformats.org/drawingml/2006/main"/>
           <a:p xmlns:a="http://schemas.openxmlformats.org/drawingml/2006/main">
             <a:pPr>
+              <a:buNone/>
               <a:defRPr sz="2400">
                 <a:solidFill>
                   <a:srgbClr val="264A54"/>
@@ -3485,11 +3575,12 @@
                 <a:ea typeface="Arial"/>
                 <a:cs typeface="Arial"/>
               </a:rPr>
-              <a:t>Автоматические проверки: права, расчёты и восстановление.</a:t>
-            </a:r>
-          </a:p>
-          <a:p xmlns:a="http://schemas.openxmlformats.org/drawingml/2006/main">
-            <a:pPr>
+              <a:t>Автопроверки: права, переходы и сохранность данных</a:t>
+            </a:r>
+          </a:p>
+          <a:p xmlns:a="http://schemas.openxmlformats.org/drawingml/2006/main">
+            <a:pPr>
+              <a:buNone/>
               <a:defRPr sz="2400">
                 <a:solidFill>
                   <a:srgbClr val="264A54"/>
@@ -3508,11 +3599,12 @@
                 <a:ea typeface="Arial"/>
                 <a:cs typeface="Arial"/>
               </a:rPr>
-              <a:t>Мобильный прогон: два iPhone, затем настоящий Android.</a:t>
-            </a:r>
-          </a:p>
-          <a:p xmlns:a="http://schemas.openxmlformats.org/drawingml/2006/main">
-            <a:pPr>
+              <a:t>Живой ИИ и русский Whisper на HTTPS-стенде</a:t>
+            </a:r>
+          </a:p>
+          <a:p xmlns:a="http://schemas.openxmlformats.org/drawingml/2006/main">
+            <a:pPr>
+              <a:buNone/>
               <a:defRPr sz="2400">
                 <a:solidFill>
                   <a:srgbClr val="264A54"/>
@@ -3531,11 +3623,12 @@
                 <a:ea typeface="Arial"/>
                 <a:cs typeface="Arial"/>
               </a:rPr>
-              <a:t>Цели: выдача ≤60 с, события ≤5 с, фото ≤10 с.</a:t>
-            </a:r>
-          </a:p>
-          <a:p xmlns:a="http://schemas.openxmlformats.org/drawingml/2006/main">
-            <a:pPr>
+              <a:t>Общий лимит ИИ: $10 с сохранением расходов</a:t>
+            </a:r>
+          </a:p>
+          <a:p xmlns:a="http://schemas.openxmlformats.org/drawingml/2006/main">
+            <a:pPr>
+              <a:buNone/>
               <a:defRPr sz="2400">
                 <a:solidFill>
                   <a:srgbClr val="264A54"/>
@@ -3554,7 +3647,31 @@
                 <a:ea typeface="Arial"/>
                 <a:cs typeface="Arial"/>
               </a:rPr>
-              <a:t>Живые Telegram и ИИ проверяются отдельно.</a:t>
+              <a:t>Мобильная приёмка и замеры отложены.</a:t>
+            </a:r>
+          </a:p>
+          <a:p xmlns:a="http://schemas.openxmlformats.org/drawingml/2006/main">
+            <a:pPr>
+              <a:buNone/>
+              <a:defRPr sz="2400">
+                <a:solidFill>
+                  <a:srgbClr val="264A54"/>
+                </a:solidFill>
+                <a:latin typeface="Arial"/>
+                <a:ea typeface="Arial"/>
+                <a:cs typeface="Arial"/>
+              </a:defRPr>
+            </a:pPr>
+            <a:r>
+              <a:rPr sz="2400">
+                <a:solidFill>
+                  <a:srgbClr val="264A54"/>
+                </a:solidFill>
+                <a:latin typeface="Arial"/>
+                <a:ea typeface="Arial"/>
+                <a:cs typeface="Arial"/>
+              </a:rPr>
+              <a:t>Точность фотопроверки на производстве не измерена.</a:t>
             </a:r>
           </a:p>
         </p:txBody>
@@ -3591,6 +3708,7 @@
           <a:lstStyle xmlns:a="http://schemas.openxmlformats.org/drawingml/2006/main"/>
           <a:p xmlns:a="http://schemas.openxmlformats.org/drawingml/2006/main">
             <a:pPr>
+              <a:buNone/>
               <a:defRPr sz="1500">
                 <a:solidFill>
                   <a:srgbClr val="667E86"/>

</xml_diff>